<commit_message>
Practice rooms: keep spot-and-fix sentences and word-bank chips Arabic-only (F2–F6, D1–D4)
English notes moved into hints so right-to-left text renders cleanly.

Co-Authored-By: Claude Opus 5.5 <noreply@anthropic.com>
Claude-Session: https://claude.ai/code/session_01QWUKnGV7MRCnE8883pixoX
</commit_message>
<xml_diff>
--- a/Development_D1/Guided_Practice/D1-L04_Practice_Room_Before_and_After.pptx
+++ b/Development_D1/Guided_Practice/D1-L04_Practice_Room_Before_and_After.pptx
@@ -14820,11 +14820,11 @@
           <a:bodyPr wrap="square" lIns="0" tIns="0" rIns="0" bIns="0" rtlCol="0" anchor="ctr"/>
           <a:lstStyle/>
           <a:p>
-            <a:pPr algn="l" indent="0" marL="0">
-              <a:buNone/>
-            </a:pPr>
-            <a:r>
-              <a:rPr lang="ar-SA" altLang="en-US" sz="2000" b="1" dirty="0">
+            <a:pPr rtl="1" algn="r" indent="0" marL="0">
+              <a:buNone/>
+            </a:pPr>
+            <a:r>
+              <a:rPr lang="ar-SA" altLang="en-US" sz="1600" b="1" dirty="0">
                 <a:solidFill>
                   <a:srgbClr val="1B3B6F"/>
                 </a:solidFill>
@@ -14832,279 +14832,9 @@
                 <a:ea typeface="Amiri" pitchFamily="2" charset="-78"/>
                 <a:cs typeface="Amiri" pitchFamily="2" charset="-78"/>
               </a:rPr>
-              <a:t>قَبْلَ</a:t>
-            </a:r>
-            <a:pPr algn="l" indent="0" marL="0">
-              <a:buNone/>
-            </a:pPr>
-            <a:r>
-              <a:rPr lang="en-US" sz="1550" b="1" dirty="0">
-                <a:solidFill>
-                  <a:srgbClr val="1B3B6F"/>
-                </a:solidFill>
-                <a:latin typeface="Calibri" pitchFamily="34" charset="0"/>
-                <a:cs typeface="Amiri" pitchFamily="2" charset="-78"/>
-              </a:rPr>
-              <a:t> · </a:t>
-            </a:r>
-            <a:pPr algn="l" indent="0" marL="0">
-              <a:buNone/>
-            </a:pPr>
-            <a:r>
-              <a:rPr lang="ar-SA" altLang="en-US" sz="2000" b="1" dirty="0">
-                <a:solidFill>
-                  <a:srgbClr val="1B3B6F"/>
-                </a:solidFill>
-                <a:latin typeface="Amiri" pitchFamily="2" charset="-78"/>
-                <a:ea typeface="Amiri" pitchFamily="2" charset="-78"/>
-                <a:cs typeface="Amiri" pitchFamily="2" charset="-78"/>
-              </a:rPr>
-              <a:t>بَعْدَ</a:t>
-            </a:r>
-            <a:pPr algn="l" indent="0" marL="0">
-              <a:buNone/>
-            </a:pPr>
-            <a:r>
-              <a:rPr lang="en-US" sz="1550" b="1" dirty="0">
-                <a:solidFill>
-                  <a:srgbClr val="1B3B6F"/>
-                </a:solidFill>
-                <a:latin typeface="Calibri" pitchFamily="34" charset="0"/>
-                <a:cs typeface="Amiri" pitchFamily="2" charset="-78"/>
-              </a:rPr>
-              <a:t> + noun  ·  </a:t>
-            </a:r>
-            <a:pPr algn="l" indent="0" marL="0">
-              <a:buNone/>
-            </a:pPr>
-            <a:r>
-              <a:rPr lang="ar-SA" altLang="en-US" sz="2000" b="1" dirty="0">
-                <a:solidFill>
-                  <a:srgbClr val="1B3B6F"/>
-                </a:solidFill>
-                <a:latin typeface="Amiri" pitchFamily="2" charset="-78"/>
-                <a:ea typeface="Amiri" pitchFamily="2" charset="-78"/>
-                <a:cs typeface="Amiri" pitchFamily="2" charset="-78"/>
-              </a:rPr>
-              <a:t>قَبْلَ أَنْ</a:t>
-            </a:r>
-            <a:pPr algn="l" indent="0" marL="0">
-              <a:buNone/>
-            </a:pPr>
-            <a:r>
-              <a:rPr lang="en-US" sz="1550" b="1" dirty="0">
-                <a:solidFill>
-                  <a:srgbClr val="1B3B6F"/>
-                </a:solidFill>
-                <a:latin typeface="Calibri" pitchFamily="34" charset="0"/>
-                <a:cs typeface="Amiri" pitchFamily="2" charset="-78"/>
-              </a:rPr>
-              <a:t> · </a:t>
-            </a:r>
-            <a:pPr algn="l" indent="0" marL="0">
-              <a:buNone/>
-            </a:pPr>
-            <a:r>
-              <a:rPr lang="ar-SA" altLang="en-US" sz="2000" b="1" dirty="0">
-                <a:solidFill>
-                  <a:srgbClr val="1B3B6F"/>
-                </a:solidFill>
-                <a:latin typeface="Amiri" pitchFamily="2" charset="-78"/>
-                <a:ea typeface="Amiri" pitchFamily="2" charset="-78"/>
-                <a:cs typeface="Amiri" pitchFamily="2" charset="-78"/>
-              </a:rPr>
-              <a:t>بَعْدَ أَنْ</a:t>
-            </a:r>
-            <a:pPr algn="l" indent="0" marL="0">
-              <a:buNone/>
-            </a:pPr>
-            <a:r>
-              <a:rPr lang="en-US" sz="1550" b="1" dirty="0">
-                <a:solidFill>
-                  <a:srgbClr val="1B3B6F"/>
-                </a:solidFill>
-                <a:latin typeface="Calibri" pitchFamily="34" charset="0"/>
-                <a:cs typeface="Amiri" pitchFamily="2" charset="-78"/>
-              </a:rPr>
-              <a:t> + verb  ·  </a:t>
-            </a:r>
-            <a:pPr algn="l" indent="0" marL="0">
-              <a:buNone/>
-            </a:pPr>
-            <a:r>
-              <a:rPr lang="ar-SA" altLang="en-US" sz="2000" b="1" dirty="0">
-                <a:solidFill>
-                  <a:srgbClr val="1B3B6F"/>
-                </a:solidFill>
-                <a:latin typeface="Amiri" pitchFamily="2" charset="-78"/>
-                <a:ea typeface="Amiri" pitchFamily="2" charset="-78"/>
-                <a:cs typeface="Amiri" pitchFamily="2" charset="-78"/>
-              </a:rPr>
-              <a:t>عِنْدَمَا</a:t>
-            </a:r>
-            <a:pPr algn="l" indent="0" marL="0">
-              <a:buNone/>
-            </a:pPr>
-            <a:r>
-              <a:rPr lang="en-US" sz="1550" b="1" dirty="0">
-                <a:solidFill>
-                  <a:srgbClr val="1B3B6F"/>
-                </a:solidFill>
-                <a:latin typeface="Calibri" pitchFamily="34" charset="0"/>
-                <a:cs typeface="Amiri" pitchFamily="2" charset="-78"/>
-              </a:rPr>
-              <a:t> · </a:t>
-            </a:r>
-            <a:pPr algn="l" indent="0" marL="0">
-              <a:buNone/>
-            </a:pPr>
-            <a:r>
-              <a:rPr lang="ar-SA" altLang="en-US" sz="2000" b="1" dirty="0">
-                <a:solidFill>
-                  <a:srgbClr val="1B3B6F"/>
-                </a:solidFill>
-                <a:latin typeface="Amiri" pitchFamily="2" charset="-78"/>
-                <a:ea typeface="Amiri" pitchFamily="2" charset="-78"/>
-                <a:cs typeface="Amiri" pitchFamily="2" charset="-78"/>
-              </a:rPr>
-              <a:t>حِينَ</a:t>
-            </a:r>
-            <a:pPr algn="l" indent="0" marL="0">
-              <a:buNone/>
-            </a:pPr>
-            <a:r>
-              <a:rPr lang="en-US" sz="1550" b="1" dirty="0">
-                <a:solidFill>
-                  <a:srgbClr val="1B3B6F"/>
-                </a:solidFill>
-                <a:latin typeface="Calibri" pitchFamily="34" charset="0"/>
-                <a:cs typeface="Amiri" pitchFamily="2" charset="-78"/>
-              </a:rPr>
-              <a:t>  ·  </a:t>
-            </a:r>
-            <a:pPr algn="l" indent="0" marL="0">
-              <a:buNone/>
-            </a:pPr>
-            <a:r>
-              <a:rPr lang="ar-SA" altLang="en-US" sz="2000" b="1" dirty="0">
-                <a:solidFill>
-                  <a:srgbClr val="1B3B6F"/>
-                </a:solidFill>
-                <a:latin typeface="Amiri" pitchFamily="2" charset="-78"/>
-                <a:ea typeface="Amiri" pitchFamily="2" charset="-78"/>
-                <a:cs typeface="Amiri" pitchFamily="2" charset="-78"/>
-              </a:rPr>
-              <a:t>بِمُجَرَّدِ أَنْ</a:t>
-            </a:r>
-            <a:pPr algn="l" indent="0" marL="0">
-              <a:buNone/>
-            </a:pPr>
-            <a:r>
-              <a:rPr lang="en-US" sz="1550" b="1" dirty="0">
-                <a:solidFill>
-                  <a:srgbClr val="1B3B6F"/>
-                </a:solidFill>
-                <a:latin typeface="Calibri" pitchFamily="34" charset="0"/>
-                <a:cs typeface="Amiri" pitchFamily="2" charset="-78"/>
-              </a:rPr>
-              <a:t>  ·  </a:t>
-            </a:r>
-            <a:pPr algn="l" indent="0" marL="0">
-              <a:buNone/>
-            </a:pPr>
-            <a:r>
-              <a:rPr lang="ar-SA" altLang="en-US" sz="2000" b="1" dirty="0">
-                <a:solidFill>
-                  <a:srgbClr val="1B3B6F"/>
-                </a:solidFill>
-                <a:latin typeface="Amiri" pitchFamily="2" charset="-78"/>
-                <a:ea typeface="Amiri" pitchFamily="2" charset="-78"/>
-                <a:cs typeface="Amiri" pitchFamily="2" charset="-78"/>
-              </a:rPr>
-              <a:t>أُرَاجِعُ دُرُوسِي</a:t>
-            </a:r>
-            <a:pPr algn="l" indent="0" marL="0">
-              <a:buNone/>
-            </a:pPr>
-            <a:r>
-              <a:rPr lang="en-US" sz="1550" b="1" dirty="0">
-                <a:solidFill>
-                  <a:srgbClr val="1B3B6F"/>
-                </a:solidFill>
-                <a:latin typeface="Calibri" pitchFamily="34" charset="0"/>
-                <a:cs typeface="Amiri" pitchFamily="2" charset="-78"/>
-              </a:rPr>
-              <a:t>  ·  </a:t>
-            </a:r>
-            <a:pPr algn="l" indent="0" marL="0">
-              <a:buNone/>
-            </a:pPr>
-            <a:r>
-              <a:rPr lang="ar-SA" altLang="en-US" sz="2000" b="1" dirty="0">
-                <a:solidFill>
-                  <a:srgbClr val="1B3B6F"/>
-                </a:solidFill>
-                <a:latin typeface="Amiri" pitchFamily="2" charset="-78"/>
-                <a:ea typeface="Amiri" pitchFamily="2" charset="-78"/>
-                <a:cs typeface="Amiri" pitchFamily="2" charset="-78"/>
-              </a:rPr>
-              <a:t>أُكْمِلُ وَاجِبِي</a:t>
-            </a:r>
-            <a:pPr algn="l" indent="0" marL="0">
-              <a:buNone/>
-            </a:pPr>
-            <a:r>
-              <a:rPr lang="en-US" sz="1550" b="1" dirty="0">
-                <a:solidFill>
-                  <a:srgbClr val="1B3B6F"/>
-                </a:solidFill>
-                <a:latin typeface="Calibri" pitchFamily="34" charset="0"/>
-                <a:cs typeface="Amiri" pitchFamily="2" charset="-78"/>
-              </a:rPr>
-              <a:t>  ·  </a:t>
-            </a:r>
-            <a:pPr algn="l" indent="0" marL="0">
-              <a:buNone/>
-            </a:pPr>
-            <a:r>
-              <a:rPr lang="ar-SA" altLang="en-US" sz="2000" b="1" dirty="0">
-                <a:solidFill>
-                  <a:srgbClr val="1B3B6F"/>
-                </a:solidFill>
-                <a:latin typeface="Amiri" pitchFamily="2" charset="-78"/>
-                <a:ea typeface="Amiri" pitchFamily="2" charset="-78"/>
-                <a:cs typeface="Amiri" pitchFamily="2" charset="-78"/>
-              </a:rPr>
-              <a:t>أُسَاعِدُ أُسْرَتِي</a:t>
-            </a:r>
-            <a:pPr algn="l" indent="0" marL="0">
-              <a:buNone/>
-            </a:pPr>
-            <a:r>
-              <a:rPr lang="en-US" sz="1550" b="1" dirty="0">
-                <a:solidFill>
-                  <a:srgbClr val="1B3B6F"/>
-                </a:solidFill>
-                <a:latin typeface="Calibri" pitchFamily="34" charset="0"/>
-                <a:cs typeface="Amiri" pitchFamily="2" charset="-78"/>
-              </a:rPr>
-              <a:t>  ·  </a:t>
-            </a:r>
-            <a:pPr algn="l" indent="0" marL="0">
-              <a:buNone/>
-            </a:pPr>
-            <a:r>
-              <a:rPr lang="ar-SA" altLang="en-US" sz="2000" b="1" dirty="0">
-                <a:solidFill>
-                  <a:srgbClr val="1B3B6F"/>
-                </a:solidFill>
-                <a:latin typeface="Amiri" pitchFamily="2" charset="-78"/>
-                <a:ea typeface="Amiri" pitchFamily="2" charset="-78"/>
-                <a:cs typeface="Amiri" pitchFamily="2" charset="-78"/>
-              </a:rPr>
-              <a:t>فِي النِّهَايَةِ</a:t>
-            </a:r>
-            <a:endParaRPr lang="en-US" sz="1550" dirty="0"/>
+              <a:t>قَبْلَ المَدْرَسَةِ · بَعْدَ الغَدَاءِ  ·  قَبْلَ أَنْ أَنَامَ · بَعْدَ أَنْ أَرْجِعَ  ·  عِنْدَمَا · حِينَ  ·  بِمُجَرَّدِ أَنْ  ·  أُرَاجِعُ دُرُوسِي  ·  أُكْمِلُ وَاجِبِي  ·  أُسَاعِدُ أُسْرَتِي  ·  فِي النِّهَايَةِ</a:t>
+            </a:r>
+            <a:endParaRPr lang="ar-SA" sz="1600" dirty="0"/>
           </a:p>
         </p:txBody>
       </p:sp>

</xml_diff>